<commit_message>
feat(module-f): add network editing and export compatibility
</commit_message>
<xml_diff>
--- a/scripts/특허도면(한백수정본V1).pptx
+++ b/scripts/특허도면(한백수정본V1).pptx
@@ -1682,8 +1682,8 @@
         </p:nvSpPr>
         <p:spPr>
           <a:xfrm>
-            <a:off x="685800" y="1143000"/>
-            <a:ext cx="5486040" cy="3085920"/>
+            <a:off x="2336800" y="1143000"/>
+            <a:ext cx="2184400" cy="3086100"/>
           </a:xfrm>
           <a:prstGeom prst="rect">
             <a:avLst/>

</xml_diff>